<commit_message>
feat(presentation): add "Take it with you" scan-to-explore QR slide to WebSockets decks
Mirrors the REST decks: left QR -> the WebSockets site, right QR -> the
Workshops & Tutorials hub. Added to deck.js source for all three decks (101,
201-python, 201-quarkus) and rebuilt the pptx. New per-deck QR assets.
</commit_message>
<xml_diff>
--- a/presentation/websockets-101/WebSockets_101-r1.0.pptx
+++ b/presentation/websockets-101/WebSockets_101-r1.0.pptx
@@ -62,9 +62,10 @@
     <p:sldId id="310" r:id="rId56"/>
     <p:sldId id="311" r:id="rId57"/>
     <p:sldId id="312" r:id="rId58"/>
+    <p:sldId id="313" r:id="rId59"/>
   </p:sldIdLst>
   <p:notesMasterIdLst>
-    <p:notesMasterId r:id="rId59"/>
+    <p:notesMasterId r:id="rId60"/>
   </p:notesMasterIdLst>
   <p:sldSz cx="12192000" cy="6858000"/>
   <p:notesSz cx="6858000" cy="12192000"/>
@@ -5158,6 +5159,94 @@
             <a:fld id="{F7021451-1387-4CA6-816F-3879F97B5CBC}" type="slidenum">
               <a:rPr lang="en-US"/>
               <a:t>57</a:t>
+            </a:fld>
+            <a:endParaRPr lang="en-US"/>
+          </a:p>
+        </p:txBody>
+      </p:sp>
+    </p:spTree>
+    <p:extLst>
+      <p:ext uri="{BB962C8B-B14F-4D97-AF65-F5344CB8AC3E}">
+        <p14:creationId xmlns:p14="http://schemas.microsoft.com/office/powerpoint/2010/main" val="1024086991"/>
+      </p:ext>
+    </p:extLst>
+  </p:cSld>
+  <p:clrMapOvr>
+    <a:masterClrMapping/>
+  </p:clrMapOvr>
+</p:notes>
+</file>
+
+<file path=ppt/notesSlides/notesSlide58.xml><?xml version="1.0" encoding="utf-8"?>
+<p:notes xmlns:a="http://schemas.openxmlformats.org/drawingml/2006/main" xmlns:r="http://schemas.openxmlformats.org/officeDocument/2006/relationships" xmlns:p="http://schemas.openxmlformats.org/presentationml/2006/main">
+  <p:cSld>
+    <p:spTree>
+      <p:nvGrpSpPr>
+        <p:cNvPr id="1" name=""/>
+        <p:cNvGrpSpPr/>
+        <p:nvPr/>
+      </p:nvGrpSpPr>
+      <p:grpSpPr>
+        <a:xfrm>
+          <a:off x="0" y="0"/>
+          <a:ext cx="0" cy="0"/>
+          <a:chOff x="0" y="0"/>
+          <a:chExt cx="0" cy="0"/>
+        </a:xfrm>
+      </p:grpSpPr>
+      <p:sp>
+        <p:nvSpPr>
+          <p:cNvPr id="2" name="Slide Image Placeholder 1"/>
+          <p:cNvSpPr>
+            <a:spLocks noGrp="1" noRot="1" noChangeAspect="1"/>
+          </p:cNvSpPr>
+          <p:nvPr>
+            <p:ph type="sldImg"/>
+          </p:nvPr>
+        </p:nvSpPr>
+        <p:spPr/>
+      </p:sp>
+      <p:sp>
+        <p:nvSpPr>
+          <p:cNvPr id="3" name="Notes Placeholder 2"/>
+          <p:cNvSpPr>
+            <a:spLocks noGrp="1"/>
+          </p:cNvSpPr>
+          <p:nvPr>
+            <p:ph type="body" idx="1"/>
+          </p:nvPr>
+        </p:nvSpPr>
+        <p:spPr/>
+        <p:txBody>
+          <a:bodyPr/>
+          <a:lstStyle/>
+          <a:p>
+            <a:r>
+              <a:rPr lang="en-US" dirty="0"/>
+              <a:t>This is the 101 concepts deck, so the two codes point where the ideas live and where the whole series lives. On the left, the site: the chapters, the AsyncAPI contracts, and the runnable both-stack examples, all public. On the right, the Workshops and Tutorials hub: every workshop, tutorial, and deck in the series in one place. Scan whichever is useful; both are on the Pattern Catalyst GitHub organization.</a:t>
+            </a:r>
+            <a:endParaRPr lang="en-US" dirty="0"/>
+          </a:p>
+        </p:txBody>
+      </p:sp>
+      <p:sp>
+        <p:nvSpPr>
+          <p:cNvPr id="4" name="Slide Number Placeholder 3"/>
+          <p:cNvSpPr>
+            <a:spLocks noGrp="1"/>
+          </p:cNvSpPr>
+          <p:nvPr>
+            <p:ph type="sldNum" sz="quarter" idx="10"/>
+          </p:nvPr>
+        </p:nvSpPr>
+        <p:spPr/>
+        <p:txBody>
+          <a:bodyPr/>
+          <a:lstStyle/>
+          <a:p>
+            <a:fld id="{F7021451-1387-4CA6-816F-3879F97B5CBC}" type="slidenum">
+              <a:rPr lang="en-US"/>
+              <a:t>58</a:t>
             </a:fld>
             <a:endParaRPr lang="en-US"/>
           </a:p>
@@ -23046,6 +23135,454 @@
 </p:sld>
 </file>
 
+<file path=ppt/slides/slide58.xml><?xml version="1.0" encoding="utf-8"?>
+<p:sld xmlns:a="http://schemas.openxmlformats.org/drawingml/2006/main" xmlns:r="http://schemas.openxmlformats.org/officeDocument/2006/relationships" xmlns:p="http://schemas.openxmlformats.org/presentationml/2006/main">
+  <p:cSld name="Slide 58">
+    <p:spTree>
+      <p:nvGrpSpPr>
+        <p:cNvPr id="1" name=""/>
+        <p:cNvGrpSpPr/>
+        <p:nvPr/>
+      </p:nvGrpSpPr>
+      <p:grpSpPr>
+        <a:xfrm>
+          <a:off x="0" y="0"/>
+          <a:ext cx="0" cy="0"/>
+          <a:chOff x="0" y="0"/>
+          <a:chExt cx="0" cy="0"/>
+        </a:xfrm>
+      </p:grpSpPr>
+      <p:sp>
+        <p:nvSpPr>
+          <p:cNvPr id="2" name="Text 0"/>
+          <p:cNvSpPr/>
+          <p:nvPr/>
+        </p:nvSpPr>
+        <p:spPr>
+          <a:xfrm>
+            <a:off x="566928" y="6364224"/>
+            <a:ext cx="914400" cy="274320"/>
+          </a:xfrm>
+          <a:prstGeom prst="rect">
+            <a:avLst/>
+          </a:prstGeom>
+          <a:noFill/>
+          <a:ln/>
+        </p:spPr>
+        <p:txBody>
+          <a:bodyPr wrap="square" rtlCol="0" anchor="ctr"/>
+          <a:lstStyle/>
+          <a:p>
+            <a:pPr algn="l" indent="0" marL="0">
+              <a:buNone/>
+            </a:pPr>
+            <a:r>
+              <a:rPr lang="en-US" sz="1000" dirty="0">
+                <a:solidFill>
+                  <a:srgbClr val="8A8A8A"/>
+                </a:solidFill>
+                <a:latin typeface="Red Hat Text" pitchFamily="34" charset="0"/>
+                <a:ea typeface="Red Hat Text" pitchFamily="34" charset="-122"/>
+                <a:cs typeface="Red Hat Text" pitchFamily="34" charset="-120"/>
+              </a:rPr>
+              <a:t>58</a:t>
+            </a:r>
+            <a:endParaRPr lang="en-US" sz="1000" dirty="0"/>
+          </a:p>
+        </p:txBody>
+      </p:sp>
+      <p:pic>
+        <p:nvPicPr>
+          <p:cNvPr id="3" name="Image 0" descr="./assets/logo-candidate-2.png">    </p:cNvPr>
+          <p:cNvPicPr>
+            <a:picLocks noChangeAspect="1"/>
+          </p:cNvPicPr>
+          <p:nvPr/>
+        </p:nvPicPr>
+        <p:blipFill>
+          <a:blip r:embed="rId1"/>
+          <a:stretch>
+            <a:fillRect/>
+          </a:stretch>
+        </p:blipFill>
+        <p:spPr>
+          <a:xfrm>
+            <a:off x="10561320" y="6355080"/>
+            <a:ext cx="1033272" cy="246888"/>
+          </a:xfrm>
+          <a:prstGeom prst="rect">
+            <a:avLst/>
+          </a:prstGeom>
+        </p:spPr>
+      </p:pic>
+      <p:sp>
+        <p:nvSpPr>
+          <p:cNvPr id="4" name="Text 1"/>
+          <p:cNvSpPr/>
+          <p:nvPr/>
+        </p:nvSpPr>
+        <p:spPr>
+          <a:xfrm>
+            <a:off x="566928" y="384048"/>
+            <a:ext cx="11055096" cy="292608"/>
+          </a:xfrm>
+          <a:prstGeom prst="rect">
+            <a:avLst/>
+          </a:prstGeom>
+          <a:noFill/>
+          <a:ln/>
+        </p:spPr>
+        <p:txBody>
+          <a:bodyPr wrap="square" rtlCol="0" anchor="ctr"/>
+          <a:lstStyle/>
+          <a:p>
+            <a:pPr algn="l" indent="0" marL="0">
+              <a:buNone/>
+            </a:pPr>
+            <a:r>
+              <a:rPr lang="en-US" sz="1200" b="1" spc="400" kern="0" dirty="0">
+                <a:solidFill>
+                  <a:srgbClr val="EE0000"/>
+                </a:solidFill>
+                <a:latin typeface="Overpass" pitchFamily="34" charset="0"/>
+                <a:ea typeface="Overpass" pitchFamily="34" charset="-122"/>
+                <a:cs typeface="Overpass" pitchFamily="34" charset="-120"/>
+              </a:rPr>
+              <a:t>SCAN TO EXPLORE</a:t>
+            </a:r>
+            <a:endParaRPr lang="en-US" sz="1200" dirty="0"/>
+          </a:p>
+        </p:txBody>
+      </p:sp>
+      <p:sp>
+        <p:nvSpPr>
+          <p:cNvPr id="5" name="Text 2"/>
+          <p:cNvSpPr/>
+          <p:nvPr/>
+        </p:nvSpPr>
+        <p:spPr>
+          <a:xfrm>
+            <a:off x="566928" y="676656"/>
+            <a:ext cx="11055096" cy="1005840"/>
+          </a:xfrm>
+          <a:prstGeom prst="rect">
+            <a:avLst/>
+          </a:prstGeom>
+          <a:noFill/>
+          <a:ln/>
+        </p:spPr>
+        <p:txBody>
+          <a:bodyPr wrap="square" rtlCol="0" anchor="t"/>
+          <a:lstStyle/>
+          <a:p>
+            <a:pPr algn="l" indent="0" marL="0">
+              <a:buNone/>
+            </a:pPr>
+            <a:r>
+              <a:rPr lang="en-US" sz="3000" b="1" dirty="0">
+                <a:solidFill>
+                  <a:srgbClr val="151515"/>
+                </a:solidFill>
+                <a:latin typeface="Overpass" pitchFamily="34" charset="0"/>
+                <a:ea typeface="Overpass" pitchFamily="34" charset="-122"/>
+                <a:cs typeface="Overpass" pitchFamily="34" charset="-120"/>
+              </a:rPr>
+              <a:t>Take it with you</a:t>
+            </a:r>
+            <a:endParaRPr lang="en-US" sz="3000" dirty="0"/>
+          </a:p>
+        </p:txBody>
+      </p:sp>
+      <p:pic>
+        <p:nvPicPr>
+          <p:cNvPr id="6" name="Image 1" descr="./assets/qr-websockets-site.png">    </p:cNvPr>
+          <p:cNvPicPr>
+            <a:picLocks noChangeAspect="1"/>
+          </p:cNvPicPr>
+          <p:nvPr/>
+        </p:nvPicPr>
+        <p:blipFill>
+          <a:blip r:embed="rId2"/>
+          <a:stretch>
+            <a:fillRect/>
+          </a:stretch>
+        </p:blipFill>
+        <p:spPr>
+          <a:xfrm>
+            <a:off x="2103120" y="1627632"/>
+            <a:ext cx="2834640" cy="2834640"/>
+          </a:xfrm>
+          <a:prstGeom prst="rect">
+            <a:avLst/>
+          </a:prstGeom>
+        </p:spPr>
+      </p:pic>
+      <p:sp>
+        <p:nvSpPr>
+          <p:cNvPr id="7" name="Text 3"/>
+          <p:cNvSpPr/>
+          <p:nvPr/>
+        </p:nvSpPr>
+        <p:spPr>
+          <a:xfrm>
+            <a:off x="1417320" y="4553712"/>
+            <a:ext cx="4206240" cy="365760"/>
+          </a:xfrm>
+          <a:prstGeom prst="rect">
+            <a:avLst/>
+          </a:prstGeom>
+          <a:noFill/>
+          <a:ln/>
+        </p:spPr>
+        <p:txBody>
+          <a:bodyPr wrap="square" rtlCol="0" anchor="ctr"/>
+          <a:lstStyle/>
+          <a:p>
+            <a:pPr algn="ctr" indent="0" marL="0">
+              <a:buNone/>
+            </a:pPr>
+            <a:r>
+              <a:rPr lang="en-US" sz="1800" b="1" dirty="0">
+                <a:solidFill>
+                  <a:srgbClr val="151515"/>
+                </a:solidFill>
+                <a:latin typeface="Overpass" pitchFamily="34" charset="0"/>
+                <a:ea typeface="Overpass" pitchFamily="34" charset="-122"/>
+                <a:cs typeface="Overpass" pitchFamily="34" charset="-120"/>
+              </a:rPr>
+              <a:t>The site</a:t>
+            </a:r>
+            <a:endParaRPr lang="en-US" sz="1800" dirty="0"/>
+          </a:p>
+        </p:txBody>
+      </p:sp>
+      <p:sp>
+        <p:nvSpPr>
+          <p:cNvPr id="8" name="Text 4"/>
+          <p:cNvSpPr/>
+          <p:nvPr/>
+        </p:nvSpPr>
+        <p:spPr>
+          <a:xfrm>
+            <a:off x="1325880" y="4937760"/>
+            <a:ext cx="4389120" cy="658368"/>
+          </a:xfrm>
+          <a:prstGeom prst="rect">
+            <a:avLst/>
+          </a:prstGeom>
+          <a:noFill/>
+          <a:ln/>
+        </p:spPr>
+        <p:txBody>
+          <a:bodyPr wrap="square" rtlCol="0" anchor="t"/>
+          <a:lstStyle/>
+          <a:p>
+            <a:pPr algn="ctr" indent="0" marL="0">
+              <a:buNone/>
+            </a:pPr>
+            <a:r>
+              <a:rPr lang="en-US" sz="1300" i="1" dirty="0">
+                <a:solidFill>
+                  <a:srgbClr val="5A5A5A"/>
+                </a:solidFill>
+                <a:latin typeface="Red Hat Text" pitchFamily="34" charset="0"/>
+                <a:ea typeface="Red Hat Text" pitchFamily="34" charset="-122"/>
+                <a:cs typeface="Red Hat Text" pitchFamily="34" charset="-120"/>
+              </a:rPr>
+              <a:t>Chapters, the AsyncAPI contracts, and both-stack runnable examples</a:t>
+            </a:r>
+            <a:endParaRPr lang="en-US" sz="1300" dirty="0"/>
+          </a:p>
+        </p:txBody>
+      </p:sp>
+      <p:sp>
+        <p:nvSpPr>
+          <p:cNvPr id="9" name="Text 5"/>
+          <p:cNvSpPr/>
+          <p:nvPr/>
+        </p:nvSpPr>
+        <p:spPr>
+          <a:xfrm>
+            <a:off x="1325880" y="5596128"/>
+            <a:ext cx="4389120" cy="292608"/>
+          </a:xfrm>
+          <a:prstGeom prst="rect">
+            <a:avLst/>
+          </a:prstGeom>
+          <a:noFill/>
+          <a:ln/>
+        </p:spPr>
+        <p:txBody>
+          <a:bodyPr wrap="square" rtlCol="0" anchor="ctr"/>
+          <a:lstStyle/>
+          <a:p>
+            <a:pPr algn="ctr" indent="0" marL="0">
+              <a:buNone/>
+            </a:pPr>
+            <a:r>
+              <a:rPr lang="en-US" sz="1000" dirty="0">
+                <a:solidFill>
+                  <a:srgbClr val="EE0000"/>
+                </a:solidFill>
+                <a:latin typeface="Red Hat Mono" pitchFamily="34" charset="0"/>
+                <a:ea typeface="Red Hat Mono" pitchFamily="34" charset="-122"/>
+                <a:cs typeface="Red Hat Mono" pitchFamily="34" charset="-120"/>
+              </a:rPr>
+              <a:t>patterncatalyst.github.io/api-patterns-and-practices-websockets</a:t>
+            </a:r>
+            <a:endParaRPr lang="en-US" sz="1000" dirty="0"/>
+          </a:p>
+        </p:txBody>
+      </p:sp>
+      <p:pic>
+        <p:nvPicPr>
+          <p:cNvPr id="10" name="Image 2" descr="./assets/qr-hub.png">    </p:cNvPr>
+          <p:cNvPicPr>
+            <a:picLocks noChangeAspect="1"/>
+          </p:cNvPicPr>
+          <p:nvPr/>
+        </p:nvPicPr>
+        <p:blipFill>
+          <a:blip r:embed="rId3"/>
+          <a:stretch>
+            <a:fillRect/>
+          </a:stretch>
+        </p:blipFill>
+        <p:spPr>
+          <a:xfrm>
+            <a:off x="7251192" y="1627632"/>
+            <a:ext cx="2834640" cy="2834640"/>
+          </a:xfrm>
+          <a:prstGeom prst="rect">
+            <a:avLst/>
+          </a:prstGeom>
+        </p:spPr>
+      </p:pic>
+      <p:sp>
+        <p:nvSpPr>
+          <p:cNvPr id="11" name="Text 6"/>
+          <p:cNvSpPr/>
+          <p:nvPr/>
+        </p:nvSpPr>
+        <p:spPr>
+          <a:xfrm>
+            <a:off x="6565392" y="4553712"/>
+            <a:ext cx="4206240" cy="365760"/>
+          </a:xfrm>
+          <a:prstGeom prst="rect">
+            <a:avLst/>
+          </a:prstGeom>
+          <a:noFill/>
+          <a:ln/>
+        </p:spPr>
+        <p:txBody>
+          <a:bodyPr wrap="square" rtlCol="0" anchor="ctr"/>
+          <a:lstStyle/>
+          <a:p>
+            <a:pPr algn="ctr" indent="0" marL="0">
+              <a:buNone/>
+            </a:pPr>
+            <a:r>
+              <a:rPr lang="en-US" sz="1800" b="1" dirty="0">
+                <a:solidFill>
+                  <a:srgbClr val="151515"/>
+                </a:solidFill>
+                <a:latin typeface="Overpass" pitchFamily="34" charset="0"/>
+                <a:ea typeface="Overpass" pitchFamily="34" charset="-122"/>
+                <a:cs typeface="Overpass" pitchFamily="34" charset="-120"/>
+              </a:rPr>
+              <a:t>Workshops &amp; Tutorials</a:t>
+            </a:r>
+            <a:endParaRPr lang="en-US" sz="1800" dirty="0"/>
+          </a:p>
+        </p:txBody>
+      </p:sp>
+      <p:sp>
+        <p:nvSpPr>
+          <p:cNvPr id="12" name="Text 7"/>
+          <p:cNvSpPr/>
+          <p:nvPr/>
+        </p:nvSpPr>
+        <p:spPr>
+          <a:xfrm>
+            <a:off x="6473952" y="4937760"/>
+            <a:ext cx="4389120" cy="658368"/>
+          </a:xfrm>
+          <a:prstGeom prst="rect">
+            <a:avLst/>
+          </a:prstGeom>
+          <a:noFill/>
+          <a:ln/>
+        </p:spPr>
+        <p:txBody>
+          <a:bodyPr wrap="square" rtlCol="0" anchor="t"/>
+          <a:lstStyle/>
+          <a:p>
+            <a:pPr algn="ctr" indent="0" marL="0">
+              <a:buNone/>
+            </a:pPr>
+            <a:r>
+              <a:rPr lang="en-US" sz="1300" i="1" dirty="0">
+                <a:solidFill>
+                  <a:srgbClr val="5A5A5A"/>
+                </a:solidFill>
+                <a:latin typeface="Red Hat Text" pitchFamily="34" charset="0"/>
+                <a:ea typeface="Red Hat Text" pitchFamily="34" charset="-122"/>
+                <a:cs typeface="Red Hat Text" pitchFamily="34" charset="-120"/>
+              </a:rPr>
+              <a:t>The whole series: every workshop, tutorial, and deck in one place</a:t>
+            </a:r>
+            <a:endParaRPr lang="en-US" sz="1300" dirty="0"/>
+          </a:p>
+        </p:txBody>
+      </p:sp>
+      <p:sp>
+        <p:nvSpPr>
+          <p:cNvPr id="13" name="Text 8"/>
+          <p:cNvSpPr/>
+          <p:nvPr/>
+        </p:nvSpPr>
+        <p:spPr>
+          <a:xfrm>
+            <a:off x="6473952" y="5596128"/>
+            <a:ext cx="4389120" cy="292608"/>
+          </a:xfrm>
+          <a:prstGeom prst="rect">
+            <a:avLst/>
+          </a:prstGeom>
+          <a:noFill/>
+          <a:ln/>
+        </p:spPr>
+        <p:txBody>
+          <a:bodyPr wrap="square" rtlCol="0" anchor="ctr"/>
+          <a:lstStyle/>
+          <a:p>
+            <a:pPr algn="ctr" indent="0" marL="0">
+              <a:buNone/>
+            </a:pPr>
+            <a:r>
+              <a:rPr lang="en-US" sz="900" dirty="0">
+                <a:solidFill>
+                  <a:srgbClr val="EE0000"/>
+                </a:solidFill>
+                <a:latin typeface="Red Hat Mono" pitchFamily="34" charset="0"/>
+                <a:ea typeface="Red Hat Mono" pitchFamily="34" charset="-122"/>
+                <a:cs typeface="Red Hat Mono" pitchFamily="34" charset="-120"/>
+              </a:rPr>
+              <a:t>patterncatalyst.github.io/patterncatalyst-workshops-tutorials-list</a:t>
+            </a:r>
+            <a:endParaRPr lang="en-US" sz="900" dirty="0"/>
+          </a:p>
+        </p:txBody>
+      </p:sp>
+    </p:spTree>
+  </p:cSld>
+  <p:clrMapOvr>
+    <a:masterClrMapping/>
+  </p:clrMapOvr>
+</p:sld>
+</file>
+
 <file path=ppt/slides/slide6.xml><?xml version="1.0" encoding="utf-8"?>
 <p:sld xmlns:a="http://schemas.openxmlformats.org/drawingml/2006/main" xmlns:r="http://schemas.openxmlformats.org/officeDocument/2006/relationships" xmlns:p="http://schemas.openxmlformats.org/presentationml/2006/main">
   <p:cSld name="Slide 6">

</xml_diff>

<commit_message>
feat(presentation): add "Take it with you" scan-to-explore QR slide to WebSockets decks (#14)
Mirrors the REST decks: left QR -> the WebSockets site, right QR -> the
Workshops & Tutorials hub. Added to deck.js source for all three decks (101,
201-python, 201-quarkus) and rebuilt the pptx. New per-deck QR assets.
</commit_message>
<xml_diff>
--- a/presentation/websockets-101/WebSockets_101-r1.0.pptx
+++ b/presentation/websockets-101/WebSockets_101-r1.0.pptx
@@ -62,9 +62,10 @@
     <p:sldId id="310" r:id="rId56"/>
     <p:sldId id="311" r:id="rId57"/>
     <p:sldId id="312" r:id="rId58"/>
+    <p:sldId id="313" r:id="rId59"/>
   </p:sldIdLst>
   <p:notesMasterIdLst>
-    <p:notesMasterId r:id="rId59"/>
+    <p:notesMasterId r:id="rId60"/>
   </p:notesMasterIdLst>
   <p:sldSz cx="12192000" cy="6858000"/>
   <p:notesSz cx="6858000" cy="12192000"/>
@@ -5158,6 +5159,94 @@
             <a:fld id="{F7021451-1387-4CA6-816F-3879F97B5CBC}" type="slidenum">
               <a:rPr lang="en-US"/>
               <a:t>57</a:t>
+            </a:fld>
+            <a:endParaRPr lang="en-US"/>
+          </a:p>
+        </p:txBody>
+      </p:sp>
+    </p:spTree>
+    <p:extLst>
+      <p:ext uri="{BB962C8B-B14F-4D97-AF65-F5344CB8AC3E}">
+        <p14:creationId xmlns:p14="http://schemas.microsoft.com/office/powerpoint/2010/main" val="1024086991"/>
+      </p:ext>
+    </p:extLst>
+  </p:cSld>
+  <p:clrMapOvr>
+    <a:masterClrMapping/>
+  </p:clrMapOvr>
+</p:notes>
+</file>
+
+<file path=ppt/notesSlides/notesSlide58.xml><?xml version="1.0" encoding="utf-8"?>
+<p:notes xmlns:a="http://schemas.openxmlformats.org/drawingml/2006/main" xmlns:r="http://schemas.openxmlformats.org/officeDocument/2006/relationships" xmlns:p="http://schemas.openxmlformats.org/presentationml/2006/main">
+  <p:cSld>
+    <p:spTree>
+      <p:nvGrpSpPr>
+        <p:cNvPr id="1" name=""/>
+        <p:cNvGrpSpPr/>
+        <p:nvPr/>
+      </p:nvGrpSpPr>
+      <p:grpSpPr>
+        <a:xfrm>
+          <a:off x="0" y="0"/>
+          <a:ext cx="0" cy="0"/>
+          <a:chOff x="0" y="0"/>
+          <a:chExt cx="0" cy="0"/>
+        </a:xfrm>
+      </p:grpSpPr>
+      <p:sp>
+        <p:nvSpPr>
+          <p:cNvPr id="2" name="Slide Image Placeholder 1"/>
+          <p:cNvSpPr>
+            <a:spLocks noGrp="1" noRot="1" noChangeAspect="1"/>
+          </p:cNvSpPr>
+          <p:nvPr>
+            <p:ph type="sldImg"/>
+          </p:nvPr>
+        </p:nvSpPr>
+        <p:spPr/>
+      </p:sp>
+      <p:sp>
+        <p:nvSpPr>
+          <p:cNvPr id="3" name="Notes Placeholder 2"/>
+          <p:cNvSpPr>
+            <a:spLocks noGrp="1"/>
+          </p:cNvSpPr>
+          <p:nvPr>
+            <p:ph type="body" idx="1"/>
+          </p:nvPr>
+        </p:nvSpPr>
+        <p:spPr/>
+        <p:txBody>
+          <a:bodyPr/>
+          <a:lstStyle/>
+          <a:p>
+            <a:r>
+              <a:rPr lang="en-US" dirty="0"/>
+              <a:t>This is the 101 concepts deck, so the two codes point where the ideas live and where the whole series lives. On the left, the site: the chapters, the AsyncAPI contracts, and the runnable both-stack examples, all public. On the right, the Workshops and Tutorials hub: every workshop, tutorial, and deck in the series in one place. Scan whichever is useful; both are on the Pattern Catalyst GitHub organization.</a:t>
+            </a:r>
+            <a:endParaRPr lang="en-US" dirty="0"/>
+          </a:p>
+        </p:txBody>
+      </p:sp>
+      <p:sp>
+        <p:nvSpPr>
+          <p:cNvPr id="4" name="Slide Number Placeholder 3"/>
+          <p:cNvSpPr>
+            <a:spLocks noGrp="1"/>
+          </p:cNvSpPr>
+          <p:nvPr>
+            <p:ph type="sldNum" sz="quarter" idx="10"/>
+          </p:nvPr>
+        </p:nvSpPr>
+        <p:spPr/>
+        <p:txBody>
+          <a:bodyPr/>
+          <a:lstStyle/>
+          <a:p>
+            <a:fld id="{F7021451-1387-4CA6-816F-3879F97B5CBC}" type="slidenum">
+              <a:rPr lang="en-US"/>
+              <a:t>58</a:t>
             </a:fld>
             <a:endParaRPr lang="en-US"/>
           </a:p>
@@ -23046,6 +23135,454 @@
 </p:sld>
 </file>
 
+<file path=ppt/slides/slide58.xml><?xml version="1.0" encoding="utf-8"?>
+<p:sld xmlns:a="http://schemas.openxmlformats.org/drawingml/2006/main" xmlns:r="http://schemas.openxmlformats.org/officeDocument/2006/relationships" xmlns:p="http://schemas.openxmlformats.org/presentationml/2006/main">
+  <p:cSld name="Slide 58">
+    <p:spTree>
+      <p:nvGrpSpPr>
+        <p:cNvPr id="1" name=""/>
+        <p:cNvGrpSpPr/>
+        <p:nvPr/>
+      </p:nvGrpSpPr>
+      <p:grpSpPr>
+        <a:xfrm>
+          <a:off x="0" y="0"/>
+          <a:ext cx="0" cy="0"/>
+          <a:chOff x="0" y="0"/>
+          <a:chExt cx="0" cy="0"/>
+        </a:xfrm>
+      </p:grpSpPr>
+      <p:sp>
+        <p:nvSpPr>
+          <p:cNvPr id="2" name="Text 0"/>
+          <p:cNvSpPr/>
+          <p:nvPr/>
+        </p:nvSpPr>
+        <p:spPr>
+          <a:xfrm>
+            <a:off x="566928" y="6364224"/>
+            <a:ext cx="914400" cy="274320"/>
+          </a:xfrm>
+          <a:prstGeom prst="rect">
+            <a:avLst/>
+          </a:prstGeom>
+          <a:noFill/>
+          <a:ln/>
+        </p:spPr>
+        <p:txBody>
+          <a:bodyPr wrap="square" rtlCol="0" anchor="ctr"/>
+          <a:lstStyle/>
+          <a:p>
+            <a:pPr algn="l" indent="0" marL="0">
+              <a:buNone/>
+            </a:pPr>
+            <a:r>
+              <a:rPr lang="en-US" sz="1000" dirty="0">
+                <a:solidFill>
+                  <a:srgbClr val="8A8A8A"/>
+                </a:solidFill>
+                <a:latin typeface="Red Hat Text" pitchFamily="34" charset="0"/>
+                <a:ea typeface="Red Hat Text" pitchFamily="34" charset="-122"/>
+                <a:cs typeface="Red Hat Text" pitchFamily="34" charset="-120"/>
+              </a:rPr>
+              <a:t>58</a:t>
+            </a:r>
+            <a:endParaRPr lang="en-US" sz="1000" dirty="0"/>
+          </a:p>
+        </p:txBody>
+      </p:sp>
+      <p:pic>
+        <p:nvPicPr>
+          <p:cNvPr id="3" name="Image 0" descr="./assets/logo-candidate-2.png">    </p:cNvPr>
+          <p:cNvPicPr>
+            <a:picLocks noChangeAspect="1"/>
+          </p:cNvPicPr>
+          <p:nvPr/>
+        </p:nvPicPr>
+        <p:blipFill>
+          <a:blip r:embed="rId1"/>
+          <a:stretch>
+            <a:fillRect/>
+          </a:stretch>
+        </p:blipFill>
+        <p:spPr>
+          <a:xfrm>
+            <a:off x="10561320" y="6355080"/>
+            <a:ext cx="1033272" cy="246888"/>
+          </a:xfrm>
+          <a:prstGeom prst="rect">
+            <a:avLst/>
+          </a:prstGeom>
+        </p:spPr>
+      </p:pic>
+      <p:sp>
+        <p:nvSpPr>
+          <p:cNvPr id="4" name="Text 1"/>
+          <p:cNvSpPr/>
+          <p:nvPr/>
+        </p:nvSpPr>
+        <p:spPr>
+          <a:xfrm>
+            <a:off x="566928" y="384048"/>
+            <a:ext cx="11055096" cy="292608"/>
+          </a:xfrm>
+          <a:prstGeom prst="rect">
+            <a:avLst/>
+          </a:prstGeom>
+          <a:noFill/>
+          <a:ln/>
+        </p:spPr>
+        <p:txBody>
+          <a:bodyPr wrap="square" rtlCol="0" anchor="ctr"/>
+          <a:lstStyle/>
+          <a:p>
+            <a:pPr algn="l" indent="0" marL="0">
+              <a:buNone/>
+            </a:pPr>
+            <a:r>
+              <a:rPr lang="en-US" sz="1200" b="1" spc="400" kern="0" dirty="0">
+                <a:solidFill>
+                  <a:srgbClr val="EE0000"/>
+                </a:solidFill>
+                <a:latin typeface="Overpass" pitchFamily="34" charset="0"/>
+                <a:ea typeface="Overpass" pitchFamily="34" charset="-122"/>
+                <a:cs typeface="Overpass" pitchFamily="34" charset="-120"/>
+              </a:rPr>
+              <a:t>SCAN TO EXPLORE</a:t>
+            </a:r>
+            <a:endParaRPr lang="en-US" sz="1200" dirty="0"/>
+          </a:p>
+        </p:txBody>
+      </p:sp>
+      <p:sp>
+        <p:nvSpPr>
+          <p:cNvPr id="5" name="Text 2"/>
+          <p:cNvSpPr/>
+          <p:nvPr/>
+        </p:nvSpPr>
+        <p:spPr>
+          <a:xfrm>
+            <a:off x="566928" y="676656"/>
+            <a:ext cx="11055096" cy="1005840"/>
+          </a:xfrm>
+          <a:prstGeom prst="rect">
+            <a:avLst/>
+          </a:prstGeom>
+          <a:noFill/>
+          <a:ln/>
+        </p:spPr>
+        <p:txBody>
+          <a:bodyPr wrap="square" rtlCol="0" anchor="t"/>
+          <a:lstStyle/>
+          <a:p>
+            <a:pPr algn="l" indent="0" marL="0">
+              <a:buNone/>
+            </a:pPr>
+            <a:r>
+              <a:rPr lang="en-US" sz="3000" b="1" dirty="0">
+                <a:solidFill>
+                  <a:srgbClr val="151515"/>
+                </a:solidFill>
+                <a:latin typeface="Overpass" pitchFamily="34" charset="0"/>
+                <a:ea typeface="Overpass" pitchFamily="34" charset="-122"/>
+                <a:cs typeface="Overpass" pitchFamily="34" charset="-120"/>
+              </a:rPr>
+              <a:t>Take it with you</a:t>
+            </a:r>
+            <a:endParaRPr lang="en-US" sz="3000" dirty="0"/>
+          </a:p>
+        </p:txBody>
+      </p:sp>
+      <p:pic>
+        <p:nvPicPr>
+          <p:cNvPr id="6" name="Image 1" descr="./assets/qr-websockets-site.png">    </p:cNvPr>
+          <p:cNvPicPr>
+            <a:picLocks noChangeAspect="1"/>
+          </p:cNvPicPr>
+          <p:nvPr/>
+        </p:nvPicPr>
+        <p:blipFill>
+          <a:blip r:embed="rId2"/>
+          <a:stretch>
+            <a:fillRect/>
+          </a:stretch>
+        </p:blipFill>
+        <p:spPr>
+          <a:xfrm>
+            <a:off x="2103120" y="1627632"/>
+            <a:ext cx="2834640" cy="2834640"/>
+          </a:xfrm>
+          <a:prstGeom prst="rect">
+            <a:avLst/>
+          </a:prstGeom>
+        </p:spPr>
+      </p:pic>
+      <p:sp>
+        <p:nvSpPr>
+          <p:cNvPr id="7" name="Text 3"/>
+          <p:cNvSpPr/>
+          <p:nvPr/>
+        </p:nvSpPr>
+        <p:spPr>
+          <a:xfrm>
+            <a:off x="1417320" y="4553712"/>
+            <a:ext cx="4206240" cy="365760"/>
+          </a:xfrm>
+          <a:prstGeom prst="rect">
+            <a:avLst/>
+          </a:prstGeom>
+          <a:noFill/>
+          <a:ln/>
+        </p:spPr>
+        <p:txBody>
+          <a:bodyPr wrap="square" rtlCol="0" anchor="ctr"/>
+          <a:lstStyle/>
+          <a:p>
+            <a:pPr algn="ctr" indent="0" marL="0">
+              <a:buNone/>
+            </a:pPr>
+            <a:r>
+              <a:rPr lang="en-US" sz="1800" b="1" dirty="0">
+                <a:solidFill>
+                  <a:srgbClr val="151515"/>
+                </a:solidFill>
+                <a:latin typeface="Overpass" pitchFamily="34" charset="0"/>
+                <a:ea typeface="Overpass" pitchFamily="34" charset="-122"/>
+                <a:cs typeface="Overpass" pitchFamily="34" charset="-120"/>
+              </a:rPr>
+              <a:t>The site</a:t>
+            </a:r>
+            <a:endParaRPr lang="en-US" sz="1800" dirty="0"/>
+          </a:p>
+        </p:txBody>
+      </p:sp>
+      <p:sp>
+        <p:nvSpPr>
+          <p:cNvPr id="8" name="Text 4"/>
+          <p:cNvSpPr/>
+          <p:nvPr/>
+        </p:nvSpPr>
+        <p:spPr>
+          <a:xfrm>
+            <a:off x="1325880" y="4937760"/>
+            <a:ext cx="4389120" cy="658368"/>
+          </a:xfrm>
+          <a:prstGeom prst="rect">
+            <a:avLst/>
+          </a:prstGeom>
+          <a:noFill/>
+          <a:ln/>
+        </p:spPr>
+        <p:txBody>
+          <a:bodyPr wrap="square" rtlCol="0" anchor="t"/>
+          <a:lstStyle/>
+          <a:p>
+            <a:pPr algn="ctr" indent="0" marL="0">
+              <a:buNone/>
+            </a:pPr>
+            <a:r>
+              <a:rPr lang="en-US" sz="1300" i="1" dirty="0">
+                <a:solidFill>
+                  <a:srgbClr val="5A5A5A"/>
+                </a:solidFill>
+                <a:latin typeface="Red Hat Text" pitchFamily="34" charset="0"/>
+                <a:ea typeface="Red Hat Text" pitchFamily="34" charset="-122"/>
+                <a:cs typeface="Red Hat Text" pitchFamily="34" charset="-120"/>
+              </a:rPr>
+              <a:t>Chapters, the AsyncAPI contracts, and both-stack runnable examples</a:t>
+            </a:r>
+            <a:endParaRPr lang="en-US" sz="1300" dirty="0"/>
+          </a:p>
+        </p:txBody>
+      </p:sp>
+      <p:sp>
+        <p:nvSpPr>
+          <p:cNvPr id="9" name="Text 5"/>
+          <p:cNvSpPr/>
+          <p:nvPr/>
+        </p:nvSpPr>
+        <p:spPr>
+          <a:xfrm>
+            <a:off x="1325880" y="5596128"/>
+            <a:ext cx="4389120" cy="292608"/>
+          </a:xfrm>
+          <a:prstGeom prst="rect">
+            <a:avLst/>
+          </a:prstGeom>
+          <a:noFill/>
+          <a:ln/>
+        </p:spPr>
+        <p:txBody>
+          <a:bodyPr wrap="square" rtlCol="0" anchor="ctr"/>
+          <a:lstStyle/>
+          <a:p>
+            <a:pPr algn="ctr" indent="0" marL="0">
+              <a:buNone/>
+            </a:pPr>
+            <a:r>
+              <a:rPr lang="en-US" sz="1000" dirty="0">
+                <a:solidFill>
+                  <a:srgbClr val="EE0000"/>
+                </a:solidFill>
+                <a:latin typeface="Red Hat Mono" pitchFamily="34" charset="0"/>
+                <a:ea typeface="Red Hat Mono" pitchFamily="34" charset="-122"/>
+                <a:cs typeface="Red Hat Mono" pitchFamily="34" charset="-120"/>
+              </a:rPr>
+              <a:t>patterncatalyst.github.io/api-patterns-and-practices-websockets</a:t>
+            </a:r>
+            <a:endParaRPr lang="en-US" sz="1000" dirty="0"/>
+          </a:p>
+        </p:txBody>
+      </p:sp>
+      <p:pic>
+        <p:nvPicPr>
+          <p:cNvPr id="10" name="Image 2" descr="./assets/qr-hub.png">    </p:cNvPr>
+          <p:cNvPicPr>
+            <a:picLocks noChangeAspect="1"/>
+          </p:cNvPicPr>
+          <p:nvPr/>
+        </p:nvPicPr>
+        <p:blipFill>
+          <a:blip r:embed="rId3"/>
+          <a:stretch>
+            <a:fillRect/>
+          </a:stretch>
+        </p:blipFill>
+        <p:spPr>
+          <a:xfrm>
+            <a:off x="7251192" y="1627632"/>
+            <a:ext cx="2834640" cy="2834640"/>
+          </a:xfrm>
+          <a:prstGeom prst="rect">
+            <a:avLst/>
+          </a:prstGeom>
+        </p:spPr>
+      </p:pic>
+      <p:sp>
+        <p:nvSpPr>
+          <p:cNvPr id="11" name="Text 6"/>
+          <p:cNvSpPr/>
+          <p:nvPr/>
+        </p:nvSpPr>
+        <p:spPr>
+          <a:xfrm>
+            <a:off x="6565392" y="4553712"/>
+            <a:ext cx="4206240" cy="365760"/>
+          </a:xfrm>
+          <a:prstGeom prst="rect">
+            <a:avLst/>
+          </a:prstGeom>
+          <a:noFill/>
+          <a:ln/>
+        </p:spPr>
+        <p:txBody>
+          <a:bodyPr wrap="square" rtlCol="0" anchor="ctr"/>
+          <a:lstStyle/>
+          <a:p>
+            <a:pPr algn="ctr" indent="0" marL="0">
+              <a:buNone/>
+            </a:pPr>
+            <a:r>
+              <a:rPr lang="en-US" sz="1800" b="1" dirty="0">
+                <a:solidFill>
+                  <a:srgbClr val="151515"/>
+                </a:solidFill>
+                <a:latin typeface="Overpass" pitchFamily="34" charset="0"/>
+                <a:ea typeface="Overpass" pitchFamily="34" charset="-122"/>
+                <a:cs typeface="Overpass" pitchFamily="34" charset="-120"/>
+              </a:rPr>
+              <a:t>Workshops &amp; Tutorials</a:t>
+            </a:r>
+            <a:endParaRPr lang="en-US" sz="1800" dirty="0"/>
+          </a:p>
+        </p:txBody>
+      </p:sp>
+      <p:sp>
+        <p:nvSpPr>
+          <p:cNvPr id="12" name="Text 7"/>
+          <p:cNvSpPr/>
+          <p:nvPr/>
+        </p:nvSpPr>
+        <p:spPr>
+          <a:xfrm>
+            <a:off x="6473952" y="4937760"/>
+            <a:ext cx="4389120" cy="658368"/>
+          </a:xfrm>
+          <a:prstGeom prst="rect">
+            <a:avLst/>
+          </a:prstGeom>
+          <a:noFill/>
+          <a:ln/>
+        </p:spPr>
+        <p:txBody>
+          <a:bodyPr wrap="square" rtlCol="0" anchor="t"/>
+          <a:lstStyle/>
+          <a:p>
+            <a:pPr algn="ctr" indent="0" marL="0">
+              <a:buNone/>
+            </a:pPr>
+            <a:r>
+              <a:rPr lang="en-US" sz="1300" i="1" dirty="0">
+                <a:solidFill>
+                  <a:srgbClr val="5A5A5A"/>
+                </a:solidFill>
+                <a:latin typeface="Red Hat Text" pitchFamily="34" charset="0"/>
+                <a:ea typeface="Red Hat Text" pitchFamily="34" charset="-122"/>
+                <a:cs typeface="Red Hat Text" pitchFamily="34" charset="-120"/>
+              </a:rPr>
+              <a:t>The whole series: every workshop, tutorial, and deck in one place</a:t>
+            </a:r>
+            <a:endParaRPr lang="en-US" sz="1300" dirty="0"/>
+          </a:p>
+        </p:txBody>
+      </p:sp>
+      <p:sp>
+        <p:nvSpPr>
+          <p:cNvPr id="13" name="Text 8"/>
+          <p:cNvSpPr/>
+          <p:nvPr/>
+        </p:nvSpPr>
+        <p:spPr>
+          <a:xfrm>
+            <a:off x="6473952" y="5596128"/>
+            <a:ext cx="4389120" cy="292608"/>
+          </a:xfrm>
+          <a:prstGeom prst="rect">
+            <a:avLst/>
+          </a:prstGeom>
+          <a:noFill/>
+          <a:ln/>
+        </p:spPr>
+        <p:txBody>
+          <a:bodyPr wrap="square" rtlCol="0" anchor="ctr"/>
+          <a:lstStyle/>
+          <a:p>
+            <a:pPr algn="ctr" indent="0" marL="0">
+              <a:buNone/>
+            </a:pPr>
+            <a:r>
+              <a:rPr lang="en-US" sz="900" dirty="0">
+                <a:solidFill>
+                  <a:srgbClr val="EE0000"/>
+                </a:solidFill>
+                <a:latin typeface="Red Hat Mono" pitchFamily="34" charset="0"/>
+                <a:ea typeface="Red Hat Mono" pitchFamily="34" charset="-122"/>
+                <a:cs typeface="Red Hat Mono" pitchFamily="34" charset="-120"/>
+              </a:rPr>
+              <a:t>patterncatalyst.github.io/patterncatalyst-workshops-tutorials-list</a:t>
+            </a:r>
+            <a:endParaRPr lang="en-US" sz="900" dirty="0"/>
+          </a:p>
+        </p:txBody>
+      </p:sp>
+    </p:spTree>
+  </p:cSld>
+  <p:clrMapOvr>
+    <a:masterClrMapping/>
+  </p:clrMapOvr>
+</p:sld>
+</file>
+
 <file path=ppt/slides/slide6.xml><?xml version="1.0" encoding="utf-8"?>
 <p:sld xmlns:a="http://schemas.openxmlformats.org/drawingml/2006/main" xmlns:r="http://schemas.openxmlformats.org/officeDocument/2006/relationships" xmlns:p="http://schemas.openxmlformats.org/presentationml/2006/main">
   <p:cSld name="Slide 6">

</xml_diff>